<commit_message>
feat: render copilot-studio-2026 revision 06 with fitted diagram labels
- re-render four voices on adapter 10 so the orchestration diamond label fits

🎙️ - Generated by Copilot

Co-authored-by: Copilot <223556219+Copilot@users.noreply.github.com>
</commit_message>
<xml_diff>
--- a/projects/copilot-studio-2026/release/outputs/deck.pptx
+++ b/projects/copilot-studio-2026/release/outputs/deck.pptx
@@ -1352,7 +1352,7 @@
                   <a:srgbClr val="BCC1C8"/>
                 </a:solidFill>
               </a:rPr>
-              <a:t>copilot-studio-2026-05-am-michael-kokoro-onnx</a:t>
+              <a:t>copilot-studio-2026-06-am-michael-kokoro-onnx</a:t>
             </a:r>
           </a:p>
         </p:txBody>
@@ -2839,7 +2839,7 @@
                   <a:srgbClr val="BCC1C8"/>
                 </a:solidFill>
               </a:rPr>
-              <a:t>copilot-studio-2026-05-am-michael-kokoro-onnx</a:t>
+              <a:t>copilot-studio-2026-06-am-michael-kokoro-onnx</a:t>
             </a:r>
           </a:p>
         </p:txBody>

</xml_diff>

<commit_message>
feat: regenerate copilot-studio-2026 with LF-stable release generation
- render four voices so release-verify passes on any checkout

🎙️ - Generated by Copilot

Co-authored-by: Copilot <223556219+Copilot@users.noreply.github.com>
</commit_message>
<xml_diff>
--- a/projects/copilot-studio-2026/release/outputs/deck.pptx
+++ b/projects/copilot-studio-2026/release/outputs/deck.pptx
@@ -1352,7 +1352,7 @@
                   <a:srgbClr val="BCC1C8"/>
                 </a:solidFill>
               </a:rPr>
-              <a:t>copilot-studio-2026-06-am-michael-kokoro-onnx</a:t>
+              <a:t>copilot-studio-2026-07-am-michael-kokoro-onnx</a:t>
             </a:r>
           </a:p>
         </p:txBody>
@@ -2839,7 +2839,7 @@
                   <a:srgbClr val="BCC1C8"/>
                 </a:solidFill>
               </a:rPr>
-              <a:t>copilot-studio-2026-06-am-michael-kokoro-onnx</a:t>
+              <a:t>copilot-studio-2026-07-am-michael-kokoro-onnx</a:t>
             </a:r>
           </a:p>
         </p:txBody>

</xml_diff>

<commit_message>
feat: regenerate copilot-studio-2026 with its brand theme
- render four voices with the brand header band, palette and fonts

🎨 - Generated by Copilot

Co-authored-by: Copilot <223556219+Copilot@users.noreply.github.com>
</commit_message>
<xml_diff>
--- a/projects/copilot-studio-2026/release/outputs/deck.pptx
+++ b/projects/copilot-studio-2026/release/outputs/deck.pptx
@@ -18,6 +18,16 @@
     <a:defPPr>
       <a:defRPr lang="en-US"/>
     </a:defPPr>
+    <a:lvl1pPr algn="l" defTabSz="914400" marL="0" indent="0">
+      <a:defRPr sz="1800" kern="1200">
+        <a:solidFill>
+          <a:schemeClr val="tx1"/>
+        </a:solidFill>
+        <a:latin typeface="+mn-lt"/>
+        <a:ea typeface="+mn-ea"/>
+        <a:cs typeface="+mn-cs"/>
+      </a:defRPr>
+    </a:lvl1pPr>
   </p:defaultTextStyle>
 </p:presentation>
 </file>
@@ -1125,7 +1135,7 @@
     <p:bg>
       <p:bgPr>
         <a:solidFill>
-          <a:srgbClr val="10233A"/>
+          <a:srgbClr val="F4F8FC"/>
         </a:solidFill>
         <a:effectLst/>
       </p:bgPr>
@@ -1139,20 +1149,20 @@
       <p:grpSpPr/>
       <p:sp>
         <p:nvSpPr>
-          <p:cNvPr id="2" name="Accent band"/>
+          <p:cNvPr id="2" name="Brand band"/>
           <p:cNvSpPr/>
           <p:nvPr/>
         </p:nvSpPr>
         <p:spPr>
           <a:xfrm>
             <a:off x="0" y="0"/>
-            <a:ext cx="12192000" cy="91440"/>
+            <a:ext cx="12192000" cy="502920"/>
           </a:xfrm>
           <a:prstGeom prst="rect">
             <a:avLst/>
           </a:prstGeom>
           <a:solidFill>
-            <a:srgbClr val="5A8CFF"/>
+            <a:srgbClr val="091F2C"/>
           </a:solidFill>
           <a:ln>
             <a:noFill/>
@@ -1161,14 +1171,36 @@
       </p:sp>
       <p:sp>
         <p:nvSpPr>
-          <p:cNvPr id="3" name="Title"/>
-          <p:cNvSpPr txBox="1"/>
-          <p:nvPr/>
-        </p:nvSpPr>
-        <p:spPr>
-          <a:xfrm>
-            <a:off x="685800" y="900000"/>
-            <a:ext cx="10820400" cy="2000000"/>
+          <p:cNvPr id="3" name="Highlight rule"/>
+          <p:cNvSpPr/>
+          <p:nvPr/>
+        </p:nvSpPr>
+        <p:spPr>
+          <a:xfrm>
+            <a:off x="0" y="502920"/>
+            <a:ext cx="12192000" cy="45720"/>
+          </a:xfrm>
+          <a:prstGeom prst="rect">
+            <a:avLst/>
+          </a:prstGeom>
+          <a:solidFill>
+            <a:srgbClr val="50E6FF"/>
+          </a:solidFill>
+          <a:ln>
+            <a:noFill/>
+          </a:ln>
+        </p:spPr>
+      </p:sp>
+      <p:sp>
+        <p:nvSpPr>
+          <p:cNvPr id="4" name="Deck kicker"/>
+          <p:cNvSpPr txBox="1"/>
+          <p:nvPr/>
+        </p:nvSpPr>
+        <p:spPr>
+          <a:xfrm>
+            <a:off x="685800" y="0"/>
+            <a:ext cx="8400000" cy="502920"/>
           </a:xfrm>
           <a:prstGeom prst="rect">
             <a:avLst/>
@@ -1193,45 +1225,74 @@
               </a:spcAft>
             </a:pPr>
             <a:r>
-              <a:rPr lang="en-US" sz="3600" b="1">
+              <a:rPr lang="en-US" sz="1100" b="1" cap="all" spc="120">
                 <a:solidFill>
                   <a:srgbClr val="FFFFFF"/>
                 </a:solidFill>
               </a:rPr>
-              <a:t>Copilot Studio 2026:</a:t>
-            </a:r>
-            <a:r>
-              <a:rPr lang="en-US" sz="3600" b="1">
-                <a:solidFill>
-                  <a:srgbClr val="5A8CFF"/>
-                </a:solidFill>
-              </a:rPr>
-              <a:t> govern intent-to-action agents</a:t>
-            </a:r>
-          </a:p>
-        </p:txBody>
-      </p:sp>
-      <p:sp>
-        <p:nvSpPr>
-          <p:cNvPr id="4" name="Summary"/>
-          <p:cNvSpPr txBox="1"/>
-          <p:nvPr/>
-        </p:nvSpPr>
-        <p:spPr>
-          <a:xfrm>
-            <a:off x="685800" y="3000000"/>
-            <a:ext cx="9600000" cy="1400000"/>
-          </a:xfrm>
-          <a:prstGeom prst="rect">
-            <a:avLst/>
-          </a:prstGeom>
-          <a:noFill/>
-          <a:ln>
-            <a:noFill/>
-          </a:ln>
-        </p:spPr>
-        <p:txBody>
-          <a:bodyPr wrap="square" lIns="182880" tIns="91440" rIns="182880" bIns="91440" anchor="t">
+              <a:t>Copilot Studio 2026</a:t>
+            </a:r>
+          </a:p>
+        </p:txBody>
+      </p:sp>
+      <p:sp>
+        <p:nvSpPr>
+          <p:cNvPr id="5" name="Slide number"/>
+          <p:cNvSpPr txBox="1"/>
+          <p:nvPr/>
+        </p:nvSpPr>
+        <p:spPr>
+          <a:xfrm>
+            <a:off x="9100000" y="0"/>
+            <a:ext cx="2406400" cy="502920"/>
+          </a:xfrm>
+          <a:prstGeom prst="rect">
+            <a:avLst/>
+          </a:prstGeom>
+          <a:noFill/>
+          <a:ln>
+            <a:noFill/>
+          </a:ln>
+        </p:spPr>
+        <p:txBody>
+          <a:bodyPr wrap="square" lIns="182880" tIns="91440" rIns="182880" bIns="91440" anchor="ctr">
+            <a:normAutofit/>
+          </a:bodyPr>
+          <a:lstStyle/>
+          <a:p>
+            <a:pPr algn="r"/>
+            <a:r>
+              <a:rPr lang="en-US" sz="1100" b="1" cap="all" spc="120">
+                <a:solidFill>
+                  <a:srgbClr val="BAC0C4"/>
+                </a:solidFill>
+              </a:rPr>
+              <a:t>1 / 6</a:t>
+            </a:r>
+          </a:p>
+        </p:txBody>
+      </p:sp>
+      <p:sp>
+        <p:nvSpPr>
+          <p:cNvPr id="6" name="Title"/>
+          <p:cNvSpPr txBox="1"/>
+          <p:nvPr/>
+        </p:nvSpPr>
+        <p:spPr>
+          <a:xfrm>
+            <a:off x="685800" y="1100000"/>
+            <a:ext cx="10820400" cy="2000000"/>
+          </a:xfrm>
+          <a:prstGeom prst="rect">
+            <a:avLst/>
+          </a:prstGeom>
+          <a:noFill/>
+          <a:ln>
+            <a:noFill/>
+          </a:ln>
+        </p:spPr>
+        <p:txBody>
+          <a:bodyPr wrap="square" lIns="182880" tIns="91440" rIns="182880" bIns="91440" anchor="ctr">
             <a:normAutofit/>
           </a:bodyPr>
           <a:lstStyle/>
@@ -1245,43 +1306,47 @@
               </a:spcAft>
             </a:pPr>
             <a:r>
-              <a:rPr lang="en-US" sz="1800">
-                <a:solidFill>
-                  <a:srgbClr val="BCC1C8"/>
-                </a:solidFill>
-              </a:rPr>
-              <a:t>Bottom line: use Copilot Studio as a governed agent platform, moving from business intent to useful action while funding workflows that merit scale, with rigor.</a:t>
-            </a:r>
-          </a:p>
-        </p:txBody>
-      </p:sp>
-      <p:sp>
-        <p:nvSpPr>
-          <p:cNvPr id="5" name="Decision"/>
-          <p:cNvSpPr/>
-          <p:nvPr/>
-        </p:nvSpPr>
-        <p:spPr>
-          <a:xfrm>
-            <a:off x="685800" y="4500000"/>
-            <a:ext cx="10820400" cy="1000000"/>
-          </a:xfrm>
-          <a:prstGeom prst="roundRect">
-            <a:avLst>
-              <a:gd name="adj" fmla="val 9000"/>
-            </a:avLst>
-          </a:prstGeom>
-          <a:solidFill>
-            <a:srgbClr val="1C345A"/>
-          </a:solidFill>
-          <a:ln w="12700">
-            <a:solidFill>
-              <a:srgbClr val="5A8CFF"/>
-            </a:solidFill>
-          </a:ln>
-        </p:spPr>
-        <p:txBody>
-          <a:bodyPr wrap="square" lIns="182880" tIns="91440" rIns="182880" bIns="91440" anchor="ctr">
+              <a:rPr lang="en-US" sz="3600" b="1">
+                <a:solidFill>
+                  <a:srgbClr val="071923"/>
+                </a:solidFill>
+                <a:latin typeface="+mj-lt"/>
+              </a:rPr>
+              <a:t>Copilot Studio 2026:</a:t>
+            </a:r>
+            <a:r>
+              <a:rPr lang="en-US" sz="3600" b="1">
+                <a:solidFill>
+                  <a:srgbClr val="006EC3"/>
+                </a:solidFill>
+                <a:latin typeface="+mj-lt"/>
+              </a:rPr>
+              <a:t> govern intent-to-action agents</a:t>
+            </a:r>
+          </a:p>
+        </p:txBody>
+      </p:sp>
+      <p:sp>
+        <p:nvSpPr>
+          <p:cNvPr id="7" name="Summary"/>
+          <p:cNvSpPr txBox="1"/>
+          <p:nvPr/>
+        </p:nvSpPr>
+        <p:spPr>
+          <a:xfrm>
+            <a:off x="685800" y="3150000"/>
+            <a:ext cx="9600000" cy="1400000"/>
+          </a:xfrm>
+          <a:prstGeom prst="rect">
+            <a:avLst/>
+          </a:prstGeom>
+          <a:noFill/>
+          <a:ln>
+            <a:noFill/>
+          </a:ln>
+        </p:spPr>
+        <p:txBody>
+          <a:bodyPr wrap="square" lIns="182880" tIns="91440" rIns="182880" bIns="91440" anchor="t">
             <a:normAutofit/>
           </a:bodyPr>
           <a:lstStyle/>
@@ -1295,45 +1360,43 @@
               </a:spcAft>
             </a:pPr>
             <a:r>
-              <a:rPr lang="en-US" sz="1400" b="1">
-                <a:solidFill>
-                  <a:srgbClr val="5A8CFF"/>
-                </a:solidFill>
-              </a:rPr>
-              <a:t>DECISION  </a:t>
-            </a:r>
-            <a:r>
-              <a:rPr lang="en-US" sz="2000" b="1">
-                <a:solidFill>
-                  <a:srgbClr val="FFFFFF"/>
-                </a:solidFill>
-              </a:rPr>
-              <a:t>Fund governed agent scale where workflows merit managed automation.</a:t>
-            </a:r>
-          </a:p>
-        </p:txBody>
-      </p:sp>
-      <p:sp>
-        <p:nvSpPr>
-          <p:cNvPr id="6" name="Footer"/>
-          <p:cNvSpPr txBox="1"/>
-          <p:nvPr/>
-        </p:nvSpPr>
-        <p:spPr>
-          <a:xfrm>
-            <a:off x="685800" y="6250000"/>
-            <a:ext cx="9400000" cy="420000"/>
-          </a:xfrm>
-          <a:prstGeom prst="rect">
-            <a:avLst/>
-          </a:prstGeom>
-          <a:noFill/>
-          <a:ln>
-            <a:noFill/>
-          </a:ln>
-        </p:spPr>
-        <p:txBody>
-          <a:bodyPr wrap="square" lIns="182880" tIns="91440" rIns="182880" bIns="91440" anchor="t">
+              <a:rPr lang="en-US" sz="1800">
+                <a:solidFill>
+                  <a:srgbClr val="626C71"/>
+                </a:solidFill>
+              </a:rPr>
+              <a:t>Bottom line: use Copilot Studio as a governed agent platform, moving from business intent to useful action while funding workflows that merit scale, with rigor.</a:t>
+            </a:r>
+          </a:p>
+        </p:txBody>
+      </p:sp>
+      <p:sp>
+        <p:nvSpPr>
+          <p:cNvPr id="8" name="Decision"/>
+          <p:cNvSpPr/>
+          <p:nvPr/>
+        </p:nvSpPr>
+        <p:spPr>
+          <a:xfrm>
+            <a:off x="685800" y="4650000"/>
+            <a:ext cx="10820400" cy="1000000"/>
+          </a:xfrm>
+          <a:prstGeom prst="roundRect">
+            <a:avLst>
+              <a:gd name="adj" fmla="val 6000"/>
+            </a:avLst>
+          </a:prstGeom>
+          <a:solidFill>
+            <a:srgbClr val="E5FBFF"/>
+          </a:solidFill>
+          <a:ln w="12700">
+            <a:solidFill>
+              <a:srgbClr val="328F9E"/>
+            </a:solidFill>
+          </a:ln>
+        </p:spPr>
+        <p:txBody>
+          <a:bodyPr wrap="square" lIns="182880" tIns="91440" rIns="182880" bIns="91440" anchor="ctr">
             <a:normAutofit/>
           </a:bodyPr>
           <a:lstStyle/>
@@ -1347,26 +1410,34 @@
               </a:spcAft>
             </a:pPr>
             <a:r>
-              <a:rPr lang="en-US" sz="1000">
-                <a:solidFill>
-                  <a:srgbClr val="BCC1C8"/>
-                </a:solidFill>
-              </a:rPr>
-              <a:t>copilot-studio-2026-07-am-michael-kokoro-onnx</a:t>
-            </a:r>
-          </a:p>
-        </p:txBody>
-      </p:sp>
-      <p:sp>
-        <p:nvSpPr>
-          <p:cNvPr id="7" name="Slide number"/>
-          <p:cNvSpPr txBox="1"/>
-          <p:nvPr/>
-        </p:nvSpPr>
-        <p:spPr>
-          <a:xfrm>
-            <a:off x="10100000" y="6250000"/>
-            <a:ext cx="1400000" cy="420000"/>
+              <a:rPr lang="en-US" sz="1400" b="1">
+                <a:solidFill>
+                  <a:srgbClr val="006EC3"/>
+                </a:solidFill>
+              </a:rPr>
+              <a:t>DECISION  </a:t>
+            </a:r>
+            <a:r>
+              <a:rPr lang="en-US" sz="2000" b="1">
+                <a:solidFill>
+                  <a:srgbClr val="071923"/>
+                </a:solidFill>
+              </a:rPr>
+              <a:t>Fund governed agent scale where workflows merit managed automation.</a:t>
+            </a:r>
+          </a:p>
+        </p:txBody>
+      </p:sp>
+      <p:sp>
+        <p:nvSpPr>
+          <p:cNvPr id="9" name="Footer"/>
+          <p:cNvSpPr txBox="1"/>
+          <p:nvPr/>
+        </p:nvSpPr>
+        <p:spPr>
+          <a:xfrm>
+            <a:off x="685800" y="6250000"/>
+            <a:ext cx="10820400" cy="420000"/>
           </a:xfrm>
           <a:prstGeom prst="rect">
             <a:avLst/>
@@ -1382,14 +1453,21 @@
           </a:bodyPr>
           <a:lstStyle/>
           <a:p>
-            <a:pPr algn="r"/>
+            <a:pPr algn="l">
+              <a:lnSpc>
+                <a:spcPct val="105000"/>
+              </a:lnSpc>
+              <a:spcAft>
+                <a:spcPts val="0"/>
+              </a:spcAft>
+            </a:pPr>
             <a:r>
               <a:rPr lang="en-US" sz="1000">
                 <a:solidFill>
-                  <a:srgbClr val="BCC1C8"/>
-                </a:solidFill>
-              </a:rPr>
-              <a:t>1 / 6</a:t>
+                  <a:srgbClr val="626C71"/>
+                </a:solidFill>
+              </a:rPr>
+              <a:t>copilot-studio-2026-08-am-michael-kokoro-onnx</a:t>
             </a:r>
           </a:p>
         </p:txBody>
@@ -1408,7 +1486,7 @@
     <p:bg>
       <p:bgPr>
         <a:solidFill>
-          <a:srgbClr val="10233A"/>
+          <a:srgbClr val="F4F8FC"/>
         </a:solidFill>
         <a:effectLst/>
       </p:bgPr>
@@ -1422,20 +1500,20 @@
       <p:grpSpPr/>
       <p:sp>
         <p:nvSpPr>
-          <p:cNvPr id="2" name="Accent band"/>
+          <p:cNvPr id="2" name="Brand band"/>
           <p:cNvSpPr/>
           <p:nvPr/>
         </p:nvSpPr>
         <p:spPr>
           <a:xfrm>
             <a:off x="0" y="0"/>
-            <a:ext cx="12192000" cy="91440"/>
+            <a:ext cx="12192000" cy="502920"/>
           </a:xfrm>
           <a:prstGeom prst="rect">
             <a:avLst/>
           </a:prstGeom>
           <a:solidFill>
-            <a:srgbClr val="5A8CFF"/>
+            <a:srgbClr val="091F2C"/>
           </a:solidFill>
           <a:ln>
             <a:noFill/>
@@ -1444,14 +1522,36 @@
       </p:sp>
       <p:sp>
         <p:nvSpPr>
-          <p:cNvPr id="3" name="Title"/>
-          <p:cNvSpPr txBox="1"/>
-          <p:nvPr/>
-        </p:nvSpPr>
-        <p:spPr>
-          <a:xfrm>
-            <a:off x="685800" y="420000"/>
-            <a:ext cx="10820400" cy="1150000"/>
+          <p:cNvPr id="3" name="Highlight rule"/>
+          <p:cNvSpPr/>
+          <p:nvPr/>
+        </p:nvSpPr>
+        <p:spPr>
+          <a:xfrm>
+            <a:off x="0" y="502920"/>
+            <a:ext cx="12192000" cy="45720"/>
+          </a:xfrm>
+          <a:prstGeom prst="rect">
+            <a:avLst/>
+          </a:prstGeom>
+          <a:solidFill>
+            <a:srgbClr val="50E6FF"/>
+          </a:solidFill>
+          <a:ln>
+            <a:noFill/>
+          </a:ln>
+        </p:spPr>
+      </p:sp>
+      <p:sp>
+        <p:nvSpPr>
+          <p:cNvPr id="4" name="Deck kicker"/>
+          <p:cNvSpPr txBox="1"/>
+          <p:nvPr/>
+        </p:nvSpPr>
+        <p:spPr>
+          <a:xfrm>
+            <a:off x="685800" y="0"/>
+            <a:ext cx="8400000" cy="502920"/>
           </a:xfrm>
           <a:prstGeom prst="rect">
             <a:avLst/>
@@ -1476,45 +1576,74 @@
               </a:spcAft>
             </a:pPr>
             <a:r>
-              <a:rPr lang="en-US" sz="2900" b="1">
+              <a:rPr lang="en-US" sz="1100" b="1" cap="all" spc="120">
                 <a:solidFill>
                   <a:srgbClr val="FFFFFF"/>
                 </a:solidFill>
               </a:rPr>
-              <a:t>1.</a:t>
-            </a:r>
-            <a:r>
-              <a:rPr lang="en-US" sz="2900" b="1">
-                <a:solidFill>
-                  <a:srgbClr val="5A8CFF"/>
-                </a:solidFill>
-              </a:rPr>
-              <a:t> Managed build surface</a:t>
-            </a:r>
-          </a:p>
-        </p:txBody>
-      </p:sp>
-      <p:sp>
-        <p:nvSpPr>
-          <p:cNvPr id="4" name="Body"/>
-          <p:cNvSpPr txBox="1"/>
-          <p:nvPr/>
-        </p:nvSpPr>
-        <p:spPr>
-          <a:xfrm>
-            <a:off x="685800" y="1750000"/>
-            <a:ext cx="3900000" cy="3900000"/>
-          </a:xfrm>
-          <a:prstGeom prst="rect">
-            <a:avLst/>
-          </a:prstGeom>
-          <a:noFill/>
-          <a:ln>
-            <a:noFill/>
-          </a:ln>
-        </p:spPr>
-        <p:txBody>
-          <a:bodyPr wrap="square" lIns="182880" tIns="91440" rIns="182880" bIns="91440" anchor="t">
+              <a:t>Copilot Studio 2026</a:t>
+            </a:r>
+          </a:p>
+        </p:txBody>
+      </p:sp>
+      <p:sp>
+        <p:nvSpPr>
+          <p:cNvPr id="5" name="Slide number"/>
+          <p:cNvSpPr txBox="1"/>
+          <p:nvPr/>
+        </p:nvSpPr>
+        <p:spPr>
+          <a:xfrm>
+            <a:off x="9100000" y="0"/>
+            <a:ext cx="2406400" cy="502920"/>
+          </a:xfrm>
+          <a:prstGeom prst="rect">
+            <a:avLst/>
+          </a:prstGeom>
+          <a:noFill/>
+          <a:ln>
+            <a:noFill/>
+          </a:ln>
+        </p:spPr>
+        <p:txBody>
+          <a:bodyPr wrap="square" lIns="182880" tIns="91440" rIns="182880" bIns="91440" anchor="ctr">
+            <a:normAutofit/>
+          </a:bodyPr>
+          <a:lstStyle/>
+          <a:p>
+            <a:pPr algn="r"/>
+            <a:r>
+              <a:rPr lang="en-US" sz="1100" b="1" cap="all" spc="120">
+                <a:solidFill>
+                  <a:srgbClr val="BAC0C4"/>
+                </a:solidFill>
+              </a:rPr>
+              <a:t>2 / 6</a:t>
+            </a:r>
+          </a:p>
+        </p:txBody>
+      </p:sp>
+      <p:sp>
+        <p:nvSpPr>
+          <p:cNvPr id="6" name="Title"/>
+          <p:cNvSpPr txBox="1"/>
+          <p:nvPr/>
+        </p:nvSpPr>
+        <p:spPr>
+          <a:xfrm>
+            <a:off x="685800" y="700000"/>
+            <a:ext cx="10820400" cy="1150000"/>
+          </a:xfrm>
+          <a:prstGeom prst="rect">
+            <a:avLst/>
+          </a:prstGeom>
+          <a:noFill/>
+          <a:ln>
+            <a:noFill/>
+          </a:ln>
+        </p:spPr>
+        <p:txBody>
+          <a:bodyPr wrap="square" lIns="182880" tIns="91440" rIns="182880" bIns="91440" anchor="ctr">
             <a:normAutofit/>
           </a:bodyPr>
           <a:lstStyle/>
@@ -1528,77 +1657,36 @@
               </a:spcAft>
             </a:pPr>
             <a:r>
-              <a:rPr lang="en-US" sz="2400">
-                <a:solidFill>
-                  <a:srgbClr val="FFFFFF"/>
-                </a:solidFill>
-              </a:rPr>
-              <a:t>Copilot Studio is a low-code studio for building and managing agents. Teams create agents, workflows and agent flows tied to business data, systems and work channels.</a:t>
-            </a:r>
-          </a:p>
-        </p:txBody>
-      </p:sp>
-      <p:sp>
-        <p:nvSpPr>
-          <p:cNvPr id="5" name="Accent rule"/>
-          <p:cNvSpPr/>
-          <p:nvPr/>
-        </p:nvSpPr>
-        <p:spPr>
-          <a:xfrm>
-            <a:off x="548640" y="1800000"/>
-            <a:ext cx="45720" cy="3800000"/>
-          </a:xfrm>
-          <a:prstGeom prst="rect">
-            <a:avLst/>
-          </a:prstGeom>
-          <a:solidFill>
-            <a:srgbClr val="5A8CFF"/>
-          </a:solidFill>
-          <a:ln>
-            <a:noFill/>
-          </a:ln>
-        </p:spPr>
-      </p:sp>
-      <p:pic>
-        <p:nvPicPr>
-          <p:cNvPr id="6" name="Asset visual-managed-build" descr="The studio connects business data and systems to workplace channels through managed agents and workflows. (mermaid diagram)"/>
-          <p:cNvPicPr>
-            <a:picLocks noChangeAspect="1"/>
-          </p:cNvPicPr>
-          <p:nvPr/>
-        </p:nvPicPr>
-        <p:blipFill>
-          <a:blip r:embed="rIdImage1"/>
-          <a:stretch>
-            <a:fillRect/>
-          </a:stretch>
-        </p:blipFill>
-        <p:spPr>
-          <a:xfrm>
-            <a:off x="5000000" y="2021875"/>
-            <a:ext cx="6500000" cy="3656250"/>
-          </a:xfrm>
-          <a:prstGeom prst="rect">
-            <a:avLst/>
-          </a:prstGeom>
-          <a:ln>
-            <a:solidFill>
-              <a:srgbClr val="D9D9D9"/>
-            </a:solidFill>
-          </a:ln>
-        </p:spPr>
-      </p:pic>
-      <p:sp>
-        <p:nvSpPr>
-          <p:cNvPr id="7" name="Footer"/>
-          <p:cNvSpPr txBox="1"/>
-          <p:nvPr/>
-        </p:nvSpPr>
-        <p:spPr>
-          <a:xfrm>
-            <a:off x="685800" y="6250000"/>
-            <a:ext cx="9400000" cy="420000"/>
+              <a:rPr lang="en-US" sz="2900" b="1">
+                <a:solidFill>
+                  <a:srgbClr val="071923"/>
+                </a:solidFill>
+                <a:latin typeface="+mj-lt"/>
+              </a:rPr>
+              <a:t>1.</a:t>
+            </a:r>
+            <a:r>
+              <a:rPr lang="en-US" sz="2900" b="1">
+                <a:solidFill>
+                  <a:srgbClr val="006EC3"/>
+                </a:solidFill>
+                <a:latin typeface="+mj-lt"/>
+              </a:rPr>
+              <a:t> Managed build surface</a:t>
+            </a:r>
+          </a:p>
+        </p:txBody>
+      </p:sp>
+      <p:sp>
+        <p:nvSpPr>
+          <p:cNvPr id="7" name="Body"/>
+          <p:cNvSpPr txBox="1"/>
+          <p:nvPr/>
+        </p:nvSpPr>
+        <p:spPr>
+          <a:xfrm>
+            <a:off x="685800" y="1950000"/>
+            <a:ext cx="3900000" cy="3900000"/>
           </a:xfrm>
           <a:prstGeom prst="rect">
             <a:avLst/>
@@ -1623,26 +1711,77 @@
               </a:spcAft>
             </a:pPr>
             <a:r>
-              <a:rPr lang="en-US" sz="1000">
-                <a:solidFill>
-                  <a:srgbClr val="BCC1C8"/>
-                </a:solidFill>
-              </a:rPr>
-              <a:t>Sources: Overview - Microsoft Copilot Studio  ·  Add tools to custom agents  ·  Security and governance</a:t>
-            </a:r>
-          </a:p>
-        </p:txBody>
-      </p:sp>
-      <p:sp>
-        <p:nvSpPr>
-          <p:cNvPr id="8" name="Slide number"/>
-          <p:cNvSpPr txBox="1"/>
-          <p:nvPr/>
-        </p:nvSpPr>
-        <p:spPr>
-          <a:xfrm>
-            <a:off x="10100000" y="6250000"/>
-            <a:ext cx="1400000" cy="420000"/>
+              <a:rPr lang="en-US" sz="2400">
+                <a:solidFill>
+                  <a:srgbClr val="071923"/>
+                </a:solidFill>
+              </a:rPr>
+              <a:t>Copilot Studio is a low-code studio for building and managing agents. Teams create agents, workflows and agent flows tied to business data, systems and work channels.</a:t>
+            </a:r>
+          </a:p>
+        </p:txBody>
+      </p:sp>
+      <p:sp>
+        <p:nvSpPr>
+          <p:cNvPr id="8" name="Accent rule"/>
+          <p:cNvSpPr/>
+          <p:nvPr/>
+        </p:nvSpPr>
+        <p:spPr>
+          <a:xfrm>
+            <a:off x="548640" y="2000000"/>
+            <a:ext cx="45720" cy="3800000"/>
+          </a:xfrm>
+          <a:prstGeom prst="rect">
+            <a:avLst/>
+          </a:prstGeom>
+          <a:solidFill>
+            <a:srgbClr val="006EC3"/>
+          </a:solidFill>
+          <a:ln>
+            <a:noFill/>
+          </a:ln>
+        </p:spPr>
+      </p:sp>
+      <p:pic>
+        <p:nvPicPr>
+          <p:cNvPr id="9" name="Asset visual-managed-build" descr="The studio connects business data and systems to workplace channels through managed agents and workflows. (mermaid diagram)"/>
+          <p:cNvPicPr>
+            <a:picLocks noChangeAspect="1"/>
+          </p:cNvPicPr>
+          <p:nvPr/>
+        </p:nvPicPr>
+        <p:blipFill>
+          <a:blip r:embed="rIdImage1"/>
+          <a:stretch>
+            <a:fillRect/>
+          </a:stretch>
+        </p:blipFill>
+        <p:spPr>
+          <a:xfrm>
+            <a:off x="5000000" y="2221875"/>
+            <a:ext cx="6500000" cy="3656250"/>
+          </a:xfrm>
+          <a:prstGeom prst="rect">
+            <a:avLst/>
+          </a:prstGeom>
+          <a:ln>
+            <a:solidFill>
+              <a:srgbClr val="D9D9D9"/>
+            </a:solidFill>
+          </a:ln>
+        </p:spPr>
+      </p:pic>
+      <p:sp>
+        <p:nvSpPr>
+          <p:cNvPr id="10" name="Footer"/>
+          <p:cNvSpPr txBox="1"/>
+          <p:nvPr/>
+        </p:nvSpPr>
+        <p:spPr>
+          <a:xfrm>
+            <a:off x="685800" y="6250000"/>
+            <a:ext cx="10820400" cy="420000"/>
           </a:xfrm>
           <a:prstGeom prst="rect">
             <a:avLst/>
@@ -1658,14 +1797,21 @@
           </a:bodyPr>
           <a:lstStyle/>
           <a:p>
-            <a:pPr algn="r"/>
+            <a:pPr algn="l">
+              <a:lnSpc>
+                <a:spcPct val="105000"/>
+              </a:lnSpc>
+              <a:spcAft>
+                <a:spcPts val="0"/>
+              </a:spcAft>
+            </a:pPr>
             <a:r>
               <a:rPr lang="en-US" sz="1000">
                 <a:solidFill>
-                  <a:srgbClr val="BCC1C8"/>
-                </a:solidFill>
-              </a:rPr>
-              <a:t>2 / 6</a:t>
+                  <a:srgbClr val="626C71"/>
+                </a:solidFill>
+              </a:rPr>
+              <a:t>Sources: Overview - Microsoft Copilot Studio  ·  Add tools to custom agents  ·  Security and governance</a:t>
             </a:r>
           </a:p>
         </p:txBody>
@@ -1684,7 +1830,7 @@
     <p:bg>
       <p:bgPr>
         <a:solidFill>
-          <a:srgbClr val="10233A"/>
+          <a:srgbClr val="F4F8FC"/>
         </a:solidFill>
         <a:effectLst/>
       </p:bgPr>
@@ -1698,20 +1844,20 @@
       <p:grpSpPr/>
       <p:sp>
         <p:nvSpPr>
-          <p:cNvPr id="2" name="Accent band"/>
+          <p:cNvPr id="2" name="Brand band"/>
           <p:cNvSpPr/>
           <p:nvPr/>
         </p:nvSpPr>
         <p:spPr>
           <a:xfrm>
             <a:off x="0" y="0"/>
-            <a:ext cx="12192000" cy="91440"/>
+            <a:ext cx="12192000" cy="502920"/>
           </a:xfrm>
           <a:prstGeom prst="rect">
             <a:avLst/>
           </a:prstGeom>
           <a:solidFill>
-            <a:srgbClr val="5A8CFF"/>
+            <a:srgbClr val="091F2C"/>
           </a:solidFill>
           <a:ln>
             <a:noFill/>
@@ -1720,14 +1866,36 @@
       </p:sp>
       <p:sp>
         <p:nvSpPr>
-          <p:cNvPr id="3" name="Title"/>
-          <p:cNvSpPr txBox="1"/>
-          <p:nvPr/>
-        </p:nvSpPr>
-        <p:spPr>
-          <a:xfrm>
-            <a:off x="685800" y="420000"/>
-            <a:ext cx="10820400" cy="1150000"/>
+          <p:cNvPr id="3" name="Highlight rule"/>
+          <p:cNvSpPr/>
+          <p:nvPr/>
+        </p:nvSpPr>
+        <p:spPr>
+          <a:xfrm>
+            <a:off x="0" y="502920"/>
+            <a:ext cx="12192000" cy="45720"/>
+          </a:xfrm>
+          <a:prstGeom prst="rect">
+            <a:avLst/>
+          </a:prstGeom>
+          <a:solidFill>
+            <a:srgbClr val="50E6FF"/>
+          </a:solidFill>
+          <a:ln>
+            <a:noFill/>
+          </a:ln>
+        </p:spPr>
+      </p:sp>
+      <p:sp>
+        <p:nvSpPr>
+          <p:cNvPr id="4" name="Deck kicker"/>
+          <p:cNvSpPr txBox="1"/>
+          <p:nvPr/>
+        </p:nvSpPr>
+        <p:spPr>
+          <a:xfrm>
+            <a:off x="685800" y="0"/>
+            <a:ext cx="8400000" cy="502920"/>
           </a:xfrm>
           <a:prstGeom prst="rect">
             <a:avLst/>
@@ -1752,45 +1920,74 @@
               </a:spcAft>
             </a:pPr>
             <a:r>
-              <a:rPr lang="en-US" sz="2900" b="1">
+              <a:rPr lang="en-US" sz="1100" b="1" cap="all" spc="120">
                 <a:solidFill>
                   <a:srgbClr val="FFFFFF"/>
                 </a:solidFill>
               </a:rPr>
-              <a:t>2.</a:t>
-            </a:r>
-            <a:r>
-              <a:rPr lang="en-US" sz="2900" b="1">
-                <a:solidFill>
-                  <a:srgbClr val="5A8CFF"/>
-                </a:solidFill>
-              </a:rPr>
-              <a:t> Orchestrate choices</a:t>
-            </a:r>
-          </a:p>
-        </p:txBody>
-      </p:sp>
-      <p:sp>
-        <p:nvSpPr>
-          <p:cNvPr id="4" name="Body"/>
-          <p:cNvSpPr txBox="1"/>
-          <p:nvPr/>
-        </p:nvSpPr>
-        <p:spPr>
-          <a:xfrm>
-            <a:off x="685800" y="1750000"/>
-            <a:ext cx="3900000" cy="3900000"/>
-          </a:xfrm>
-          <a:prstGeom prst="rect">
-            <a:avLst/>
-          </a:prstGeom>
-          <a:noFill/>
-          <a:ln>
-            <a:noFill/>
-          </a:ln>
-        </p:spPr>
-        <p:txBody>
-          <a:bodyPr wrap="square" lIns="182880" tIns="91440" rIns="182880" bIns="91440" anchor="t">
+              <a:t>Copilot Studio 2026</a:t>
+            </a:r>
+          </a:p>
+        </p:txBody>
+      </p:sp>
+      <p:sp>
+        <p:nvSpPr>
+          <p:cNvPr id="5" name="Slide number"/>
+          <p:cNvSpPr txBox="1"/>
+          <p:nvPr/>
+        </p:nvSpPr>
+        <p:spPr>
+          <a:xfrm>
+            <a:off x="9100000" y="0"/>
+            <a:ext cx="2406400" cy="502920"/>
+          </a:xfrm>
+          <a:prstGeom prst="rect">
+            <a:avLst/>
+          </a:prstGeom>
+          <a:noFill/>
+          <a:ln>
+            <a:noFill/>
+          </a:ln>
+        </p:spPr>
+        <p:txBody>
+          <a:bodyPr wrap="square" lIns="182880" tIns="91440" rIns="182880" bIns="91440" anchor="ctr">
+            <a:normAutofit/>
+          </a:bodyPr>
+          <a:lstStyle/>
+          <a:p>
+            <a:pPr algn="r"/>
+            <a:r>
+              <a:rPr lang="en-US" sz="1100" b="1" cap="all" spc="120">
+                <a:solidFill>
+                  <a:srgbClr val="BAC0C4"/>
+                </a:solidFill>
+              </a:rPr>
+              <a:t>3 / 6</a:t>
+            </a:r>
+          </a:p>
+        </p:txBody>
+      </p:sp>
+      <p:sp>
+        <p:nvSpPr>
+          <p:cNvPr id="6" name="Title"/>
+          <p:cNvSpPr txBox="1"/>
+          <p:nvPr/>
+        </p:nvSpPr>
+        <p:spPr>
+          <a:xfrm>
+            <a:off x="685800" y="700000"/>
+            <a:ext cx="10820400" cy="1150000"/>
+          </a:xfrm>
+          <a:prstGeom prst="rect">
+            <a:avLst/>
+          </a:prstGeom>
+          <a:noFill/>
+          <a:ln>
+            <a:noFill/>
+          </a:ln>
+        </p:spPr>
+        <p:txBody>
+          <a:bodyPr wrap="square" lIns="182880" tIns="91440" rIns="182880" bIns="91440" anchor="ctr">
             <a:normAutofit/>
           </a:bodyPr>
           <a:lstStyle/>
@@ -1804,77 +2001,36 @@
               </a:spcAft>
             </a:pPr>
             <a:r>
-              <a:rPr lang="en-US" sz="2400">
-                <a:solidFill>
-                  <a:srgbClr val="FFFFFF"/>
-                </a:solidFill>
-              </a:rPr>
-              <a:t>Generative orchestration is the decision layer. It lets an agent choose topics, tools, knowledge or other agents, ask for missing input, and then compose the response.</a:t>
-            </a:r>
-          </a:p>
-        </p:txBody>
-      </p:sp>
-      <p:sp>
-        <p:nvSpPr>
-          <p:cNvPr id="5" name="Accent rule"/>
-          <p:cNvSpPr/>
-          <p:nvPr/>
-        </p:nvSpPr>
-        <p:spPr>
-          <a:xfrm>
-            <a:off x="548640" y="1800000"/>
-            <a:ext cx="45720" cy="3800000"/>
-          </a:xfrm>
-          <a:prstGeom prst="rect">
-            <a:avLst/>
-          </a:prstGeom>
-          <a:solidFill>
-            <a:srgbClr val="5A8CFF"/>
-          </a:solidFill>
-          <a:ln>
-            <a:noFill/>
-          </a:ln>
-        </p:spPr>
-      </p:sp>
-      <p:pic>
-        <p:nvPicPr>
-          <p:cNvPr id="6" name="Asset visual-orchestrate-choices" descr="A readable routing model: one request can route to knowledge, tools, topics or other agents. (excalidraw diagram)"/>
-          <p:cNvPicPr>
-            <a:picLocks noChangeAspect="1"/>
-          </p:cNvPicPr>
-          <p:nvPr/>
-        </p:nvPicPr>
-        <p:blipFill>
-          <a:blip r:embed="rIdImage1"/>
-          <a:stretch>
-            <a:fillRect/>
-          </a:stretch>
-        </p:blipFill>
-        <p:spPr>
-          <a:xfrm>
-            <a:off x="5000000" y="2021875"/>
-            <a:ext cx="6500000" cy="3656250"/>
-          </a:xfrm>
-          <a:prstGeom prst="rect">
-            <a:avLst/>
-          </a:prstGeom>
-          <a:ln>
-            <a:solidFill>
-              <a:srgbClr val="D9D9D9"/>
-            </a:solidFill>
-          </a:ln>
-        </p:spPr>
-      </p:pic>
-      <p:sp>
-        <p:nvSpPr>
-          <p:cNvPr id="7" name="Footer"/>
-          <p:cNvSpPr txBox="1"/>
-          <p:nvPr/>
-        </p:nvSpPr>
-        <p:spPr>
-          <a:xfrm>
-            <a:off x="685800" y="6250000"/>
-            <a:ext cx="9400000" cy="420000"/>
+              <a:rPr lang="en-US" sz="2900" b="1">
+                <a:solidFill>
+                  <a:srgbClr val="071923"/>
+                </a:solidFill>
+                <a:latin typeface="+mj-lt"/>
+              </a:rPr>
+              <a:t>2.</a:t>
+            </a:r>
+            <a:r>
+              <a:rPr lang="en-US" sz="2900" b="1">
+                <a:solidFill>
+                  <a:srgbClr val="006EC3"/>
+                </a:solidFill>
+                <a:latin typeface="+mj-lt"/>
+              </a:rPr>
+              <a:t> Orchestrate choices</a:t>
+            </a:r>
+          </a:p>
+        </p:txBody>
+      </p:sp>
+      <p:sp>
+        <p:nvSpPr>
+          <p:cNvPr id="7" name="Body"/>
+          <p:cNvSpPr txBox="1"/>
+          <p:nvPr/>
+        </p:nvSpPr>
+        <p:spPr>
+          <a:xfrm>
+            <a:off x="685800" y="1950000"/>
+            <a:ext cx="3900000" cy="3900000"/>
           </a:xfrm>
           <a:prstGeom prst="rect">
             <a:avLst/>
@@ -1899,26 +2055,77 @@
               </a:spcAft>
             </a:pPr>
             <a:r>
-              <a:rPr lang="en-US" sz="1000">
-                <a:solidFill>
-                  <a:srgbClr val="BCC1C8"/>
-                </a:solidFill>
-              </a:rPr>
-              <a:t>Sources: Orchestrate agent behavior with generative AI</a:t>
-            </a:r>
-          </a:p>
-        </p:txBody>
-      </p:sp>
-      <p:sp>
-        <p:nvSpPr>
-          <p:cNvPr id="8" name="Slide number"/>
-          <p:cNvSpPr txBox="1"/>
-          <p:nvPr/>
-        </p:nvSpPr>
-        <p:spPr>
-          <a:xfrm>
-            <a:off x="10100000" y="6250000"/>
-            <a:ext cx="1400000" cy="420000"/>
+              <a:rPr lang="en-US" sz="2400">
+                <a:solidFill>
+                  <a:srgbClr val="071923"/>
+                </a:solidFill>
+              </a:rPr>
+              <a:t>Generative orchestration is the decision layer. It lets an agent choose topics, tools, knowledge or other agents, ask for missing input, and then compose the response.</a:t>
+            </a:r>
+          </a:p>
+        </p:txBody>
+      </p:sp>
+      <p:sp>
+        <p:nvSpPr>
+          <p:cNvPr id="8" name="Accent rule"/>
+          <p:cNvSpPr/>
+          <p:nvPr/>
+        </p:nvSpPr>
+        <p:spPr>
+          <a:xfrm>
+            <a:off x="548640" y="2000000"/>
+            <a:ext cx="45720" cy="3800000"/>
+          </a:xfrm>
+          <a:prstGeom prst="rect">
+            <a:avLst/>
+          </a:prstGeom>
+          <a:solidFill>
+            <a:srgbClr val="006EC3"/>
+          </a:solidFill>
+          <a:ln>
+            <a:noFill/>
+          </a:ln>
+        </p:spPr>
+      </p:sp>
+      <p:pic>
+        <p:nvPicPr>
+          <p:cNvPr id="9" name="Asset visual-orchestrate-choices" descr="A readable routing model: one request can route to knowledge, tools, topics or other agents. (excalidraw diagram)"/>
+          <p:cNvPicPr>
+            <a:picLocks noChangeAspect="1"/>
+          </p:cNvPicPr>
+          <p:nvPr/>
+        </p:nvPicPr>
+        <p:blipFill>
+          <a:blip r:embed="rIdImage1"/>
+          <a:stretch>
+            <a:fillRect/>
+          </a:stretch>
+        </p:blipFill>
+        <p:spPr>
+          <a:xfrm>
+            <a:off x="5000000" y="2221875"/>
+            <a:ext cx="6500000" cy="3656250"/>
+          </a:xfrm>
+          <a:prstGeom prst="rect">
+            <a:avLst/>
+          </a:prstGeom>
+          <a:ln>
+            <a:solidFill>
+              <a:srgbClr val="D9D9D9"/>
+            </a:solidFill>
+          </a:ln>
+        </p:spPr>
+      </p:pic>
+      <p:sp>
+        <p:nvSpPr>
+          <p:cNvPr id="10" name="Footer"/>
+          <p:cNvSpPr txBox="1"/>
+          <p:nvPr/>
+        </p:nvSpPr>
+        <p:spPr>
+          <a:xfrm>
+            <a:off x="685800" y="6250000"/>
+            <a:ext cx="10820400" cy="420000"/>
           </a:xfrm>
           <a:prstGeom prst="rect">
             <a:avLst/>
@@ -1934,14 +2141,21 @@
           </a:bodyPr>
           <a:lstStyle/>
           <a:p>
-            <a:pPr algn="r"/>
+            <a:pPr algn="l">
+              <a:lnSpc>
+                <a:spcPct val="105000"/>
+              </a:lnSpc>
+              <a:spcAft>
+                <a:spcPts val="0"/>
+              </a:spcAft>
+            </a:pPr>
             <a:r>
               <a:rPr lang="en-US" sz="1000">
                 <a:solidFill>
-                  <a:srgbClr val="BCC1C8"/>
-                </a:solidFill>
-              </a:rPr>
-              <a:t>3 / 6</a:t>
+                  <a:srgbClr val="626C71"/>
+                </a:solidFill>
+              </a:rPr>
+              <a:t>Sources: Orchestrate agent behavior with generative AI</a:t>
             </a:r>
           </a:p>
         </p:txBody>
@@ -1960,7 +2174,7 @@
     <p:bg>
       <p:bgPr>
         <a:solidFill>
-          <a:srgbClr val="10233A"/>
+          <a:srgbClr val="F4F8FC"/>
         </a:solidFill>
         <a:effectLst/>
       </p:bgPr>
@@ -1974,20 +2188,20 @@
       <p:grpSpPr/>
       <p:sp>
         <p:nvSpPr>
-          <p:cNvPr id="2" name="Accent band"/>
+          <p:cNvPr id="2" name="Brand band"/>
           <p:cNvSpPr/>
           <p:nvPr/>
         </p:nvSpPr>
         <p:spPr>
           <a:xfrm>
             <a:off x="0" y="0"/>
-            <a:ext cx="12192000" cy="91440"/>
+            <a:ext cx="12192000" cy="502920"/>
           </a:xfrm>
           <a:prstGeom prst="rect">
             <a:avLst/>
           </a:prstGeom>
           <a:solidFill>
-            <a:srgbClr val="5A8CFF"/>
+            <a:srgbClr val="091F2C"/>
           </a:solidFill>
           <a:ln>
             <a:noFill/>
@@ -1996,14 +2210,36 @@
       </p:sp>
       <p:sp>
         <p:nvSpPr>
-          <p:cNvPr id="3" name="Title"/>
-          <p:cNvSpPr txBox="1"/>
-          <p:nvPr/>
-        </p:nvSpPr>
-        <p:spPr>
-          <a:xfrm>
-            <a:off x="685800" y="420000"/>
-            <a:ext cx="10820400" cy="1150000"/>
+          <p:cNvPr id="3" name="Highlight rule"/>
+          <p:cNvSpPr/>
+          <p:nvPr/>
+        </p:nvSpPr>
+        <p:spPr>
+          <a:xfrm>
+            <a:off x="0" y="502920"/>
+            <a:ext cx="12192000" cy="45720"/>
+          </a:xfrm>
+          <a:prstGeom prst="rect">
+            <a:avLst/>
+          </a:prstGeom>
+          <a:solidFill>
+            <a:srgbClr val="50E6FF"/>
+          </a:solidFill>
+          <a:ln>
+            <a:noFill/>
+          </a:ln>
+        </p:spPr>
+      </p:sp>
+      <p:sp>
+        <p:nvSpPr>
+          <p:cNvPr id="4" name="Deck kicker"/>
+          <p:cNvSpPr txBox="1"/>
+          <p:nvPr/>
+        </p:nvSpPr>
+        <p:spPr>
+          <a:xfrm>
+            <a:off x="685800" y="0"/>
+            <a:ext cx="8400000" cy="502920"/>
           </a:xfrm>
           <a:prstGeom prst="rect">
             <a:avLst/>
@@ -2028,45 +2264,74 @@
               </a:spcAft>
             </a:pPr>
             <a:r>
-              <a:rPr lang="en-US" sz="2900" b="1">
+              <a:rPr lang="en-US" sz="1100" b="1" cap="all" spc="120">
                 <a:solidFill>
                   <a:srgbClr val="FFFFFF"/>
                 </a:solidFill>
               </a:rPr>
-              <a:t>3.</a:t>
-            </a:r>
-            <a:r>
-              <a:rPr lang="en-US" sz="2900" b="1">
-                <a:solidFill>
-                  <a:srgbClr val="5A8CFF"/>
-                </a:solidFill>
-              </a:rPr>
-              <a:t> Tools execute work</a:t>
-            </a:r>
-          </a:p>
-        </p:txBody>
-      </p:sp>
-      <p:sp>
-        <p:nvSpPr>
-          <p:cNvPr id="4" name="Body"/>
-          <p:cNvSpPr txBox="1"/>
-          <p:nvPr/>
-        </p:nvSpPr>
-        <p:spPr>
-          <a:xfrm>
-            <a:off x="685800" y="1750000"/>
-            <a:ext cx="3900000" cy="3900000"/>
-          </a:xfrm>
-          <a:prstGeom prst="rect">
-            <a:avLst/>
-          </a:prstGeom>
-          <a:noFill/>
-          <a:ln>
-            <a:noFill/>
-          </a:ln>
-        </p:spPr>
-        <p:txBody>
-          <a:bodyPr wrap="square" lIns="182880" tIns="91440" rIns="182880" bIns="91440" anchor="t">
+              <a:t>Copilot Studio 2026</a:t>
+            </a:r>
+          </a:p>
+        </p:txBody>
+      </p:sp>
+      <p:sp>
+        <p:nvSpPr>
+          <p:cNvPr id="5" name="Slide number"/>
+          <p:cNvSpPr txBox="1"/>
+          <p:nvPr/>
+        </p:nvSpPr>
+        <p:spPr>
+          <a:xfrm>
+            <a:off x="9100000" y="0"/>
+            <a:ext cx="2406400" cy="502920"/>
+          </a:xfrm>
+          <a:prstGeom prst="rect">
+            <a:avLst/>
+          </a:prstGeom>
+          <a:noFill/>
+          <a:ln>
+            <a:noFill/>
+          </a:ln>
+        </p:spPr>
+        <p:txBody>
+          <a:bodyPr wrap="square" lIns="182880" tIns="91440" rIns="182880" bIns="91440" anchor="ctr">
+            <a:normAutofit/>
+          </a:bodyPr>
+          <a:lstStyle/>
+          <a:p>
+            <a:pPr algn="r"/>
+            <a:r>
+              <a:rPr lang="en-US" sz="1100" b="1" cap="all" spc="120">
+                <a:solidFill>
+                  <a:srgbClr val="BAC0C4"/>
+                </a:solidFill>
+              </a:rPr>
+              <a:t>4 / 6</a:t>
+            </a:r>
+          </a:p>
+        </p:txBody>
+      </p:sp>
+      <p:sp>
+        <p:nvSpPr>
+          <p:cNvPr id="6" name="Title"/>
+          <p:cNvSpPr txBox="1"/>
+          <p:nvPr/>
+        </p:nvSpPr>
+        <p:spPr>
+          <a:xfrm>
+            <a:off x="685800" y="700000"/>
+            <a:ext cx="10820400" cy="1150000"/>
+          </a:xfrm>
+          <a:prstGeom prst="rect">
+            <a:avLst/>
+          </a:prstGeom>
+          <a:noFill/>
+          <a:ln>
+            <a:noFill/>
+          </a:ln>
+        </p:spPr>
+        <p:txBody>
+          <a:bodyPr wrap="square" lIns="182880" tIns="91440" rIns="182880" bIns="91440" anchor="ctr">
             <a:normAutofit/>
           </a:bodyPr>
           <a:lstStyle/>
@@ -2080,77 +2345,36 @@
               </a:spcAft>
             </a:pPr>
             <a:r>
-              <a:rPr lang="en-US" sz="2400">
-                <a:solidFill>
-                  <a:srgbClr val="FFFFFF"/>
-                </a:solidFill>
-              </a:rPr>
-              <a:t>Tools are where intent turns into action. Govern connectors, agent flows, prompts, REST APIs, MCP and computer use for both modern apps and legacy screens under policy.</a:t>
-            </a:r>
-          </a:p>
-        </p:txBody>
-      </p:sp>
-      <p:sp>
-        <p:nvSpPr>
-          <p:cNvPr id="5" name="Accent rule"/>
-          <p:cNvSpPr/>
-          <p:nvPr/>
-        </p:nvSpPr>
-        <p:spPr>
-          <a:xfrm>
-            <a:off x="548640" y="1800000"/>
-            <a:ext cx="45720" cy="3800000"/>
-          </a:xfrm>
-          <a:prstGeom prst="rect">
-            <a:avLst/>
-          </a:prstGeom>
-          <a:solidFill>
-            <a:srgbClr val="5A8CFF"/>
-          </a:solidFill>
-          <a:ln>
-            <a:noFill/>
-          </a:ln>
-        </p:spPr>
-      </p:sp>
-      <p:pic>
-        <p:nvPicPr>
-          <p:cNvPr id="6" name="Asset visual-tools-execute" descr="Tool routes convert intent into action, but each route should be governed before scale. (marp diagram)"/>
-          <p:cNvPicPr>
-            <a:picLocks noChangeAspect="1"/>
-          </p:cNvPicPr>
-          <p:nvPr/>
-        </p:nvPicPr>
-        <p:blipFill>
-          <a:blip r:embed="rIdImage1"/>
-          <a:stretch>
-            <a:fillRect/>
-          </a:stretch>
-        </p:blipFill>
-        <p:spPr>
-          <a:xfrm>
-            <a:off x="5000000" y="2021875"/>
-            <a:ext cx="6500000" cy="3656250"/>
-          </a:xfrm>
-          <a:prstGeom prst="rect">
-            <a:avLst/>
-          </a:prstGeom>
-          <a:ln>
-            <a:solidFill>
-              <a:srgbClr val="D9D9D9"/>
-            </a:solidFill>
-          </a:ln>
-        </p:spPr>
-      </p:pic>
-      <p:sp>
-        <p:nvSpPr>
-          <p:cNvPr id="7" name="Footer"/>
-          <p:cNvSpPr txBox="1"/>
-          <p:nvPr/>
-        </p:nvSpPr>
-        <p:spPr>
-          <a:xfrm>
-            <a:off x="685800" y="6250000"/>
-            <a:ext cx="9400000" cy="420000"/>
+              <a:rPr lang="en-US" sz="2900" b="1">
+                <a:solidFill>
+                  <a:srgbClr val="071923"/>
+                </a:solidFill>
+                <a:latin typeface="+mj-lt"/>
+              </a:rPr>
+              <a:t>3.</a:t>
+            </a:r>
+            <a:r>
+              <a:rPr lang="en-US" sz="2900" b="1">
+                <a:solidFill>
+                  <a:srgbClr val="006EC3"/>
+                </a:solidFill>
+                <a:latin typeface="+mj-lt"/>
+              </a:rPr>
+              <a:t> Tools execute work</a:t>
+            </a:r>
+          </a:p>
+        </p:txBody>
+      </p:sp>
+      <p:sp>
+        <p:nvSpPr>
+          <p:cNvPr id="7" name="Body"/>
+          <p:cNvSpPr txBox="1"/>
+          <p:nvPr/>
+        </p:nvSpPr>
+        <p:spPr>
+          <a:xfrm>
+            <a:off x="685800" y="1950000"/>
+            <a:ext cx="3900000" cy="3900000"/>
           </a:xfrm>
           <a:prstGeom prst="rect">
             <a:avLst/>
@@ -2175,26 +2399,77 @@
               </a:spcAft>
             </a:pPr>
             <a:r>
-              <a:rPr lang="en-US" sz="1000">
-                <a:solidFill>
-                  <a:srgbClr val="BCC1C8"/>
-                </a:solidFill>
-              </a:rPr>
-              <a:t>Sources: Add tools to custom agents</a:t>
-            </a:r>
-          </a:p>
-        </p:txBody>
-      </p:sp>
-      <p:sp>
-        <p:nvSpPr>
-          <p:cNvPr id="8" name="Slide number"/>
-          <p:cNvSpPr txBox="1"/>
-          <p:nvPr/>
-        </p:nvSpPr>
-        <p:spPr>
-          <a:xfrm>
-            <a:off x="10100000" y="6250000"/>
-            <a:ext cx="1400000" cy="420000"/>
+              <a:rPr lang="en-US" sz="2400">
+                <a:solidFill>
+                  <a:srgbClr val="071923"/>
+                </a:solidFill>
+              </a:rPr>
+              <a:t>Tools are where intent turns into action. Govern connectors, agent flows, prompts, REST APIs, MCP and computer use for both modern apps and legacy screens under policy.</a:t>
+            </a:r>
+          </a:p>
+        </p:txBody>
+      </p:sp>
+      <p:sp>
+        <p:nvSpPr>
+          <p:cNvPr id="8" name="Accent rule"/>
+          <p:cNvSpPr/>
+          <p:nvPr/>
+        </p:nvSpPr>
+        <p:spPr>
+          <a:xfrm>
+            <a:off x="548640" y="2000000"/>
+            <a:ext cx="45720" cy="3800000"/>
+          </a:xfrm>
+          <a:prstGeom prst="rect">
+            <a:avLst/>
+          </a:prstGeom>
+          <a:solidFill>
+            <a:srgbClr val="006EC3"/>
+          </a:solidFill>
+          <a:ln>
+            <a:noFill/>
+          </a:ln>
+        </p:spPr>
+      </p:sp>
+      <p:pic>
+        <p:nvPicPr>
+          <p:cNvPr id="9" name="Asset visual-tools-execute" descr="Tool routes convert intent into action, but each route should be governed before scale. (marp diagram)"/>
+          <p:cNvPicPr>
+            <a:picLocks noChangeAspect="1"/>
+          </p:cNvPicPr>
+          <p:nvPr/>
+        </p:nvPicPr>
+        <p:blipFill>
+          <a:blip r:embed="rIdImage1"/>
+          <a:stretch>
+            <a:fillRect/>
+          </a:stretch>
+        </p:blipFill>
+        <p:spPr>
+          <a:xfrm>
+            <a:off x="5000000" y="2221875"/>
+            <a:ext cx="6500000" cy="3656250"/>
+          </a:xfrm>
+          <a:prstGeom prst="rect">
+            <a:avLst/>
+          </a:prstGeom>
+          <a:ln>
+            <a:solidFill>
+              <a:srgbClr val="D9D9D9"/>
+            </a:solidFill>
+          </a:ln>
+        </p:spPr>
+      </p:pic>
+      <p:sp>
+        <p:nvSpPr>
+          <p:cNvPr id="10" name="Footer"/>
+          <p:cNvSpPr txBox="1"/>
+          <p:nvPr/>
+        </p:nvSpPr>
+        <p:spPr>
+          <a:xfrm>
+            <a:off x="685800" y="6250000"/>
+            <a:ext cx="10820400" cy="420000"/>
           </a:xfrm>
           <a:prstGeom prst="rect">
             <a:avLst/>
@@ -2210,14 +2485,21 @@
           </a:bodyPr>
           <a:lstStyle/>
           <a:p>
-            <a:pPr algn="r"/>
+            <a:pPr algn="l">
+              <a:lnSpc>
+                <a:spcPct val="105000"/>
+              </a:lnSpc>
+              <a:spcAft>
+                <a:spcPts val="0"/>
+              </a:spcAft>
+            </a:pPr>
             <a:r>
               <a:rPr lang="en-US" sz="1000">
                 <a:solidFill>
-                  <a:srgbClr val="BCC1C8"/>
-                </a:solidFill>
-              </a:rPr>
-              <a:t>4 / 6</a:t>
+                  <a:srgbClr val="626C71"/>
+                </a:solidFill>
+              </a:rPr>
+              <a:t>Sources: Add tools to custom agents</a:t>
             </a:r>
           </a:p>
         </p:txBody>
@@ -2236,7 +2518,7 @@
     <p:bg>
       <p:bgPr>
         <a:solidFill>
-          <a:srgbClr val="10233A"/>
+          <a:srgbClr val="F4F8FC"/>
         </a:solidFill>
         <a:effectLst/>
       </p:bgPr>
@@ -2250,20 +2532,20 @@
       <p:grpSpPr/>
       <p:sp>
         <p:nvSpPr>
-          <p:cNvPr id="2" name="Accent band"/>
+          <p:cNvPr id="2" name="Brand band"/>
           <p:cNvSpPr/>
           <p:nvPr/>
         </p:nvSpPr>
         <p:spPr>
           <a:xfrm>
             <a:off x="0" y="0"/>
-            <a:ext cx="12192000" cy="91440"/>
+            <a:ext cx="12192000" cy="502920"/>
           </a:xfrm>
           <a:prstGeom prst="rect">
             <a:avLst/>
           </a:prstGeom>
           <a:solidFill>
-            <a:srgbClr val="5A8CFF"/>
+            <a:srgbClr val="091F2C"/>
           </a:solidFill>
           <a:ln>
             <a:noFill/>
@@ -2272,14 +2554,36 @@
       </p:sp>
       <p:sp>
         <p:nvSpPr>
-          <p:cNvPr id="3" name="Title"/>
-          <p:cNvSpPr txBox="1"/>
-          <p:nvPr/>
-        </p:nvSpPr>
-        <p:spPr>
-          <a:xfrm>
-            <a:off x="685800" y="420000"/>
-            <a:ext cx="10820400" cy="1150000"/>
+          <p:cNvPr id="3" name="Highlight rule"/>
+          <p:cNvSpPr/>
+          <p:nvPr/>
+        </p:nvSpPr>
+        <p:spPr>
+          <a:xfrm>
+            <a:off x="0" y="502920"/>
+            <a:ext cx="12192000" cy="45720"/>
+          </a:xfrm>
+          <a:prstGeom prst="rect">
+            <a:avLst/>
+          </a:prstGeom>
+          <a:solidFill>
+            <a:srgbClr val="50E6FF"/>
+          </a:solidFill>
+          <a:ln>
+            <a:noFill/>
+          </a:ln>
+        </p:spPr>
+      </p:sp>
+      <p:sp>
+        <p:nvSpPr>
+          <p:cNvPr id="4" name="Deck kicker"/>
+          <p:cNvSpPr txBox="1"/>
+          <p:nvPr/>
+        </p:nvSpPr>
+        <p:spPr>
+          <a:xfrm>
+            <a:off x="685800" y="0"/>
+            <a:ext cx="8400000" cy="502920"/>
           </a:xfrm>
           <a:prstGeom prst="rect">
             <a:avLst/>
@@ -2304,45 +2608,74 @@
               </a:spcAft>
             </a:pPr>
             <a:r>
-              <a:rPr lang="en-US" sz="2900" b="1">
+              <a:rPr lang="en-US" sz="1100" b="1" cap="all" spc="120">
                 <a:solidFill>
                   <a:srgbClr val="FFFFFF"/>
                 </a:solidFill>
               </a:rPr>
-              <a:t>4.</a:t>
-            </a:r>
-            <a:r>
-              <a:rPr lang="en-US" sz="2900" b="1">
-                <a:solidFill>
-                  <a:srgbClr val="5A8CFF"/>
-                </a:solidFill>
-              </a:rPr>
-              <a:t> Govern the platform</a:t>
-            </a:r>
-          </a:p>
-        </p:txBody>
-      </p:sp>
-      <p:sp>
-        <p:nvSpPr>
-          <p:cNvPr id="4" name="Body"/>
-          <p:cNvSpPr txBox="1"/>
-          <p:nvPr/>
-        </p:nvSpPr>
-        <p:spPr>
-          <a:xfrm>
-            <a:off x="685800" y="1750000"/>
-            <a:ext cx="3900000" cy="3900000"/>
-          </a:xfrm>
-          <a:prstGeom prst="rect">
-            <a:avLst/>
-          </a:prstGeom>
-          <a:noFill/>
-          <a:ln>
-            <a:noFill/>
-          </a:ln>
-        </p:spPr>
-        <p:txBody>
-          <a:bodyPr wrap="square" lIns="182880" tIns="91440" rIns="182880" bIns="91440" anchor="t">
+              <a:t>Copilot Studio 2026</a:t>
+            </a:r>
+          </a:p>
+        </p:txBody>
+      </p:sp>
+      <p:sp>
+        <p:nvSpPr>
+          <p:cNvPr id="5" name="Slide number"/>
+          <p:cNvSpPr txBox="1"/>
+          <p:nvPr/>
+        </p:nvSpPr>
+        <p:spPr>
+          <a:xfrm>
+            <a:off x="9100000" y="0"/>
+            <a:ext cx="2406400" cy="502920"/>
+          </a:xfrm>
+          <a:prstGeom prst="rect">
+            <a:avLst/>
+          </a:prstGeom>
+          <a:noFill/>
+          <a:ln>
+            <a:noFill/>
+          </a:ln>
+        </p:spPr>
+        <p:txBody>
+          <a:bodyPr wrap="square" lIns="182880" tIns="91440" rIns="182880" bIns="91440" anchor="ctr">
+            <a:normAutofit/>
+          </a:bodyPr>
+          <a:lstStyle/>
+          <a:p>
+            <a:pPr algn="r"/>
+            <a:r>
+              <a:rPr lang="en-US" sz="1100" b="1" cap="all" spc="120">
+                <a:solidFill>
+                  <a:srgbClr val="BAC0C4"/>
+                </a:solidFill>
+              </a:rPr>
+              <a:t>5 / 6</a:t>
+            </a:r>
+          </a:p>
+        </p:txBody>
+      </p:sp>
+      <p:sp>
+        <p:nvSpPr>
+          <p:cNvPr id="6" name="Title"/>
+          <p:cNvSpPr txBox="1"/>
+          <p:nvPr/>
+        </p:nvSpPr>
+        <p:spPr>
+          <a:xfrm>
+            <a:off x="685800" y="700000"/>
+            <a:ext cx="10820400" cy="1150000"/>
+          </a:xfrm>
+          <a:prstGeom prst="rect">
+            <a:avLst/>
+          </a:prstGeom>
+          <a:noFill/>
+          <a:ln>
+            <a:noFill/>
+          </a:ln>
+        </p:spPr>
+        <p:txBody>
+          <a:bodyPr wrap="square" lIns="182880" tIns="91440" rIns="182880" bIns="91440" anchor="ctr">
             <a:normAutofit/>
           </a:bodyPr>
           <a:lstStyle/>
@@ -2356,77 +2689,36 @@
               </a:spcAft>
             </a:pPr>
             <a:r>
-              <a:rPr lang="en-US" sz="2400">
-                <a:solidFill>
-                  <a:srgbClr val="FFFFFF"/>
-                </a:solidFill>
-              </a:rPr>
-              <a:t>Scale only with enterprise controls attached. Data policies, audit logs, Agent 365, Entra identities, spend controls and evaluations keep the platform managed at scale.</a:t>
-            </a:r>
-          </a:p>
-        </p:txBody>
-      </p:sp>
-      <p:sp>
-        <p:nvSpPr>
-          <p:cNvPr id="5" name="Accent rule"/>
-          <p:cNvSpPr/>
-          <p:nvPr/>
-        </p:nvSpPr>
-        <p:spPr>
-          <a:xfrm>
-            <a:off x="548640" y="1800000"/>
-            <a:ext cx="45720" cy="3800000"/>
-          </a:xfrm>
-          <a:prstGeom prst="rect">
-            <a:avLst/>
-          </a:prstGeom>
-          <a:solidFill>
-            <a:srgbClr val="5A8CFF"/>
-          </a:solidFill>
-          <a:ln>
-            <a:noFill/>
-          </a:ln>
-        </p:spPr>
-      </p:sp>
-      <p:pic>
-        <p:nvPicPr>
-          <p:cNvPr id="6" name="Asset visual-govern-platform" descr="A control board keeps scale tied to identity, policy, audit, cost and quality evidence. (marp diagram)"/>
-          <p:cNvPicPr>
-            <a:picLocks noChangeAspect="1"/>
-          </p:cNvPicPr>
-          <p:nvPr/>
-        </p:nvPicPr>
-        <p:blipFill>
-          <a:blip r:embed="rIdImage1"/>
-          <a:stretch>
-            <a:fillRect/>
-          </a:stretch>
-        </p:blipFill>
-        <p:spPr>
-          <a:xfrm>
-            <a:off x="5000000" y="2021875"/>
-            <a:ext cx="6500000" cy="3656250"/>
-          </a:xfrm>
-          <a:prstGeom prst="rect">
-            <a:avLst/>
-          </a:prstGeom>
-          <a:ln>
-            <a:solidFill>
-              <a:srgbClr val="D9D9D9"/>
-            </a:solidFill>
-          </a:ln>
-        </p:spPr>
-      </p:pic>
-      <p:sp>
-        <p:nvSpPr>
-          <p:cNvPr id="7" name="Footer"/>
-          <p:cNvSpPr txBox="1"/>
-          <p:nvPr/>
-        </p:nvSpPr>
-        <p:spPr>
-          <a:xfrm>
-            <a:off x="685800" y="6250000"/>
-            <a:ext cx="9400000" cy="420000"/>
+              <a:rPr lang="en-US" sz="2900" b="1">
+                <a:solidFill>
+                  <a:srgbClr val="071923"/>
+                </a:solidFill>
+                <a:latin typeface="+mj-lt"/>
+              </a:rPr>
+              <a:t>4.</a:t>
+            </a:r>
+            <a:r>
+              <a:rPr lang="en-US" sz="2900" b="1">
+                <a:solidFill>
+                  <a:srgbClr val="006EC3"/>
+                </a:solidFill>
+                <a:latin typeface="+mj-lt"/>
+              </a:rPr>
+              <a:t> Govern the platform</a:t>
+            </a:r>
+          </a:p>
+        </p:txBody>
+      </p:sp>
+      <p:sp>
+        <p:nvSpPr>
+          <p:cNvPr id="7" name="Body"/>
+          <p:cNvSpPr txBox="1"/>
+          <p:nvPr/>
+        </p:nvSpPr>
+        <p:spPr>
+          <a:xfrm>
+            <a:off x="685800" y="1950000"/>
+            <a:ext cx="3900000" cy="3900000"/>
           </a:xfrm>
           <a:prstGeom prst="rect">
             <a:avLst/>
@@ -2451,26 +2743,77 @@
               </a:spcAft>
             </a:pPr>
             <a:r>
-              <a:rPr lang="en-US" sz="1000">
-                <a:solidFill>
-                  <a:srgbClr val="BCC1C8"/>
-                </a:solidFill>
-              </a:rPr>
-              <a:t>Sources: Security and governance  ·  Add tools to custom agents  ·  Overview - Microsoft Copilot Studio</a:t>
-            </a:r>
-          </a:p>
-        </p:txBody>
-      </p:sp>
-      <p:sp>
-        <p:nvSpPr>
-          <p:cNvPr id="8" name="Slide number"/>
-          <p:cNvSpPr txBox="1"/>
-          <p:nvPr/>
-        </p:nvSpPr>
-        <p:spPr>
-          <a:xfrm>
-            <a:off x="10100000" y="6250000"/>
-            <a:ext cx="1400000" cy="420000"/>
+              <a:rPr lang="en-US" sz="2400">
+                <a:solidFill>
+                  <a:srgbClr val="071923"/>
+                </a:solidFill>
+              </a:rPr>
+              <a:t>Scale only with enterprise controls attached. Data policies, audit logs, Agent 365, Entra identities, spend controls and evaluations keep the platform managed at scale.</a:t>
+            </a:r>
+          </a:p>
+        </p:txBody>
+      </p:sp>
+      <p:sp>
+        <p:nvSpPr>
+          <p:cNvPr id="8" name="Accent rule"/>
+          <p:cNvSpPr/>
+          <p:nvPr/>
+        </p:nvSpPr>
+        <p:spPr>
+          <a:xfrm>
+            <a:off x="548640" y="2000000"/>
+            <a:ext cx="45720" cy="3800000"/>
+          </a:xfrm>
+          <a:prstGeom prst="rect">
+            <a:avLst/>
+          </a:prstGeom>
+          <a:solidFill>
+            <a:srgbClr val="006EC3"/>
+          </a:solidFill>
+          <a:ln>
+            <a:noFill/>
+          </a:ln>
+        </p:spPr>
+      </p:sp>
+      <p:pic>
+        <p:nvPicPr>
+          <p:cNvPr id="9" name="Asset visual-govern-platform" descr="A control board keeps scale tied to identity, policy, audit, cost and quality evidence. (marp diagram)"/>
+          <p:cNvPicPr>
+            <a:picLocks noChangeAspect="1"/>
+          </p:cNvPicPr>
+          <p:nvPr/>
+        </p:nvPicPr>
+        <p:blipFill>
+          <a:blip r:embed="rIdImage1"/>
+          <a:stretch>
+            <a:fillRect/>
+          </a:stretch>
+        </p:blipFill>
+        <p:spPr>
+          <a:xfrm>
+            <a:off x="5000000" y="2221875"/>
+            <a:ext cx="6500000" cy="3656250"/>
+          </a:xfrm>
+          <a:prstGeom prst="rect">
+            <a:avLst/>
+          </a:prstGeom>
+          <a:ln>
+            <a:solidFill>
+              <a:srgbClr val="D9D9D9"/>
+            </a:solidFill>
+          </a:ln>
+        </p:spPr>
+      </p:pic>
+      <p:sp>
+        <p:nvSpPr>
+          <p:cNvPr id="10" name="Footer"/>
+          <p:cNvSpPr txBox="1"/>
+          <p:nvPr/>
+        </p:nvSpPr>
+        <p:spPr>
+          <a:xfrm>
+            <a:off x="685800" y="6250000"/>
+            <a:ext cx="10820400" cy="420000"/>
           </a:xfrm>
           <a:prstGeom prst="rect">
             <a:avLst/>
@@ -2486,14 +2829,21 @@
           </a:bodyPr>
           <a:lstStyle/>
           <a:p>
-            <a:pPr algn="r"/>
+            <a:pPr algn="l">
+              <a:lnSpc>
+                <a:spcPct val="105000"/>
+              </a:lnSpc>
+              <a:spcAft>
+                <a:spcPts val="0"/>
+              </a:spcAft>
+            </a:pPr>
             <a:r>
               <a:rPr lang="en-US" sz="1000">
                 <a:solidFill>
-                  <a:srgbClr val="BCC1C8"/>
-                </a:solidFill>
-              </a:rPr>
-              <a:t>5 / 6</a:t>
+                  <a:srgbClr val="626C71"/>
+                </a:solidFill>
+              </a:rPr>
+              <a:t>Sources: Security and governance  ·  Add tools to custom agents  ·  Overview - Microsoft Copilot Studio</a:t>
             </a:r>
           </a:p>
         </p:txBody>
@@ -2512,7 +2862,7 @@
     <p:bg>
       <p:bgPr>
         <a:solidFill>
-          <a:srgbClr val="10233A"/>
+          <a:srgbClr val="F4F8FC"/>
         </a:solidFill>
         <a:effectLst/>
       </p:bgPr>
@@ -2526,20 +2876,20 @@
       <p:grpSpPr/>
       <p:sp>
         <p:nvSpPr>
-          <p:cNvPr id="2" name="Accent band"/>
+          <p:cNvPr id="2" name="Brand band"/>
           <p:cNvSpPr/>
           <p:nvPr/>
         </p:nvSpPr>
         <p:spPr>
           <a:xfrm>
             <a:off x="0" y="0"/>
-            <a:ext cx="12192000" cy="91440"/>
+            <a:ext cx="12192000" cy="502920"/>
           </a:xfrm>
           <a:prstGeom prst="rect">
             <a:avLst/>
           </a:prstGeom>
           <a:solidFill>
-            <a:srgbClr val="5A8CFF"/>
+            <a:srgbClr val="091F2C"/>
           </a:solidFill>
           <a:ln>
             <a:noFill/>
@@ -2548,14 +2898,36 @@
       </p:sp>
       <p:sp>
         <p:nvSpPr>
-          <p:cNvPr id="3" name="Title"/>
-          <p:cNvSpPr txBox="1"/>
-          <p:nvPr/>
-        </p:nvSpPr>
-        <p:spPr>
-          <a:xfrm>
-            <a:off x="685800" y="420000"/>
-            <a:ext cx="10820400" cy="1000000"/>
+          <p:cNvPr id="3" name="Highlight rule"/>
+          <p:cNvSpPr/>
+          <p:nvPr/>
+        </p:nvSpPr>
+        <p:spPr>
+          <a:xfrm>
+            <a:off x="0" y="502920"/>
+            <a:ext cx="12192000" cy="45720"/>
+          </a:xfrm>
+          <a:prstGeom prst="rect">
+            <a:avLst/>
+          </a:prstGeom>
+          <a:solidFill>
+            <a:srgbClr val="50E6FF"/>
+          </a:solidFill>
+          <a:ln>
+            <a:noFill/>
+          </a:ln>
+        </p:spPr>
+      </p:sp>
+      <p:sp>
+        <p:nvSpPr>
+          <p:cNvPr id="4" name="Deck kicker"/>
+          <p:cNvSpPr txBox="1"/>
+          <p:nvPr/>
+        </p:nvSpPr>
+        <p:spPr>
+          <a:xfrm>
+            <a:off x="685800" y="0"/>
+            <a:ext cx="8400000" cy="502920"/>
           </a:xfrm>
           <a:prstGeom prst="rect">
             <a:avLst/>
@@ -2580,45 +2952,74 @@
               </a:spcAft>
             </a:pPr>
             <a:r>
-              <a:rPr lang="en-US" sz="2400" b="1">
+              <a:rPr lang="en-US" sz="1100" b="1" cap="all" spc="120">
                 <a:solidFill>
                   <a:srgbClr val="FFFFFF"/>
                 </a:solidFill>
               </a:rPr>
-              <a:t>Sources.</a:t>
-            </a:r>
-            <a:r>
-              <a:rPr lang="en-US" sz="2400" b="1">
-                <a:solidFill>
-                  <a:srgbClr val="5A8CFF"/>
-                </a:solidFill>
-              </a:rPr>
-              <a:t> Every claim traces to one.</a:t>
-            </a:r>
-          </a:p>
-        </p:txBody>
-      </p:sp>
-      <p:sp>
-        <p:nvSpPr>
-          <p:cNvPr id="4" name="Sources"/>
-          <p:cNvSpPr txBox="1"/>
-          <p:nvPr/>
-        </p:nvSpPr>
-        <p:spPr>
-          <a:xfrm>
-            <a:off x="685800" y="1700000"/>
-            <a:ext cx="10820400" cy="4300000"/>
-          </a:xfrm>
-          <a:prstGeom prst="rect">
-            <a:avLst/>
-          </a:prstGeom>
-          <a:noFill/>
-          <a:ln>
-            <a:noFill/>
-          </a:ln>
-        </p:spPr>
-        <p:txBody>
-          <a:bodyPr wrap="square" lIns="182880" tIns="91440" rIns="182880" bIns="91440" anchor="t">
+              <a:t>Copilot Studio 2026</a:t>
+            </a:r>
+          </a:p>
+        </p:txBody>
+      </p:sp>
+      <p:sp>
+        <p:nvSpPr>
+          <p:cNvPr id="5" name="Slide number"/>
+          <p:cNvSpPr txBox="1"/>
+          <p:nvPr/>
+        </p:nvSpPr>
+        <p:spPr>
+          <a:xfrm>
+            <a:off x="9100000" y="0"/>
+            <a:ext cx="2406400" cy="502920"/>
+          </a:xfrm>
+          <a:prstGeom prst="rect">
+            <a:avLst/>
+          </a:prstGeom>
+          <a:noFill/>
+          <a:ln>
+            <a:noFill/>
+          </a:ln>
+        </p:spPr>
+        <p:txBody>
+          <a:bodyPr wrap="square" lIns="182880" tIns="91440" rIns="182880" bIns="91440" anchor="ctr">
+            <a:normAutofit/>
+          </a:bodyPr>
+          <a:lstStyle/>
+          <a:p>
+            <a:pPr algn="r"/>
+            <a:r>
+              <a:rPr lang="en-US" sz="1100" b="1" cap="all" spc="120">
+                <a:solidFill>
+                  <a:srgbClr val="BAC0C4"/>
+                </a:solidFill>
+              </a:rPr>
+              <a:t>6 / 6</a:t>
+            </a:r>
+          </a:p>
+        </p:txBody>
+      </p:sp>
+      <p:sp>
+        <p:nvSpPr>
+          <p:cNvPr id="6" name="Title"/>
+          <p:cNvSpPr txBox="1"/>
+          <p:nvPr/>
+        </p:nvSpPr>
+        <p:spPr>
+          <a:xfrm>
+            <a:off x="685800" y="760000"/>
+            <a:ext cx="10820400" cy="1000000"/>
+          </a:xfrm>
+          <a:prstGeom prst="rect">
+            <a:avLst/>
+          </a:prstGeom>
+          <a:noFill/>
+          <a:ln>
+            <a:noFill/>
+          </a:ln>
+        </p:spPr>
+        <p:txBody>
+          <a:bodyPr wrap="square" lIns="182880" tIns="91440" rIns="182880" bIns="91440" anchor="ctr">
             <a:normAutofit/>
           </a:bodyPr>
           <a:lstStyle/>
@@ -2632,9 +3033,63 @@
               </a:spcAft>
             </a:pPr>
             <a:r>
+              <a:rPr lang="en-US" sz="2400" b="1">
+                <a:solidFill>
+                  <a:srgbClr val="071923"/>
+                </a:solidFill>
+                <a:latin typeface="+mj-lt"/>
+              </a:rPr>
+              <a:t>Sources.</a:t>
+            </a:r>
+            <a:r>
+              <a:rPr lang="en-US" sz="2400" b="1">
+                <a:solidFill>
+                  <a:srgbClr val="006EC3"/>
+                </a:solidFill>
+                <a:latin typeface="+mj-lt"/>
+              </a:rPr>
+              <a:t> Every claim traces to one.</a:t>
+            </a:r>
+          </a:p>
+        </p:txBody>
+      </p:sp>
+      <p:sp>
+        <p:nvSpPr>
+          <p:cNvPr id="7" name="Sources"/>
+          <p:cNvSpPr txBox="1"/>
+          <p:nvPr/>
+        </p:nvSpPr>
+        <p:spPr>
+          <a:xfrm>
+            <a:off x="685800" y="1900000"/>
+            <a:ext cx="10820400" cy="4300000"/>
+          </a:xfrm>
+          <a:prstGeom prst="rect">
+            <a:avLst/>
+          </a:prstGeom>
+          <a:noFill/>
+          <a:ln>
+            <a:noFill/>
+          </a:ln>
+        </p:spPr>
+        <p:txBody>
+          <a:bodyPr wrap="square" lIns="182880" tIns="91440" rIns="182880" bIns="91440" anchor="t">
+            <a:normAutofit/>
+          </a:bodyPr>
+          <a:lstStyle/>
+          <a:p>
+            <a:pPr algn="l">
+              <a:lnSpc>
+                <a:spcPct val="105000"/>
+              </a:lnSpc>
+              <a:spcAft>
+                <a:spcPts val="0"/>
+              </a:spcAft>
+            </a:pPr>
+            <a:r>
               <a:rPr lang="en-US" sz="1400" b="1">
                 <a:solidFill>
-                  <a:srgbClr val="FFFFFF"/>
+                  <a:srgbClr val="071923"/>
                 </a:solidFill>
               </a:rPr>
               <a:t>Overview - Microsoft Copilot Studio</a:t>
@@ -2642,7 +3097,7 @@
             <a:r>
               <a:rPr lang="en-US" sz="1100">
                 <a:solidFill>
-                  <a:srgbClr val="BCC1C8"/>
+                  <a:srgbClr val="626C71"/>
                 </a:solidFill>
               </a:rPr>
               <a:t>  retrieved 2026-10-06</a:t>
@@ -2660,7 +3115,7 @@
             <a:r>
               <a:rPr lang="en-US" sz="1100">
                 <a:solidFill>
-                  <a:srgbClr val="5A8CFF"/>
+                  <a:srgbClr val="006EC3"/>
                 </a:solidFill>
               </a:rPr>
               <a:t>https://learn.microsoft.com/en-us/microsoft-copilot-studio/fundamentals-what-is-copilot-studio</a:t>
@@ -2678,7 +3133,7 @@
             <a:r>
               <a:rPr lang="en-US" sz="1400" b="1">
                 <a:solidFill>
-                  <a:srgbClr val="FFFFFF"/>
+                  <a:srgbClr val="071923"/>
                 </a:solidFill>
               </a:rPr>
               <a:t>Orchestrate agent behavior with generative AI</a:t>
@@ -2686,7 +3141,7 @@
             <a:r>
               <a:rPr lang="en-US" sz="1100">
                 <a:solidFill>
-                  <a:srgbClr val="BCC1C8"/>
+                  <a:srgbClr val="626C71"/>
                 </a:solidFill>
               </a:rPr>
               <a:t>  retrieved 2026-10-06</a:t>
@@ -2704,7 +3159,7 @@
             <a:r>
               <a:rPr lang="en-US" sz="1100">
                 <a:solidFill>
-                  <a:srgbClr val="5A8CFF"/>
+                  <a:srgbClr val="006EC3"/>
                 </a:solidFill>
               </a:rPr>
               <a:t>https://learn.microsoft.com/en-us/microsoft-copilot-studio/advanced-generative-actions</a:t>
@@ -2722,7 +3177,7 @@
             <a:r>
               <a:rPr lang="en-US" sz="1400" b="1">
                 <a:solidFill>
-                  <a:srgbClr val="FFFFFF"/>
+                  <a:srgbClr val="071923"/>
                 </a:solidFill>
               </a:rPr>
               <a:t>Add tools to custom agents</a:t>
@@ -2730,7 +3185,7 @@
             <a:r>
               <a:rPr lang="en-US" sz="1100">
                 <a:solidFill>
-                  <a:srgbClr val="BCC1C8"/>
+                  <a:srgbClr val="626C71"/>
                 </a:solidFill>
               </a:rPr>
               <a:t>  retrieved 2026-10-06</a:t>
@@ -2748,7 +3203,7 @@
             <a:r>
               <a:rPr lang="en-US" sz="1100">
                 <a:solidFill>
-                  <a:srgbClr val="5A8CFF"/>
+                  <a:srgbClr val="006EC3"/>
                 </a:solidFill>
               </a:rPr>
               <a:t>https://learn.microsoft.com/en-us/microsoft-copilot-studio/add-tools-custom-agent</a:t>
@@ -2766,7 +3221,7 @@
             <a:r>
               <a:rPr lang="en-US" sz="1400" b="1">
                 <a:solidFill>
-                  <a:srgbClr val="FFFFFF"/>
+                  <a:srgbClr val="071923"/>
                 </a:solidFill>
               </a:rPr>
               <a:t>Security and governance</a:t>
@@ -2774,7 +3229,7 @@
             <a:r>
               <a:rPr lang="en-US" sz="1100">
                 <a:solidFill>
-                  <a:srgbClr val="BCC1C8"/>
+                  <a:srgbClr val="626C71"/>
                 </a:solidFill>
               </a:rPr>
               <a:t>  retrieved 2026-10-06</a:t>
@@ -2792,7 +3247,7 @@
             <a:r>
               <a:rPr lang="en-US" sz="1100">
                 <a:solidFill>
-                  <a:srgbClr val="5A8CFF"/>
+                  <a:srgbClr val="006EC3"/>
                 </a:solidFill>
               </a:rPr>
               <a:t>https://learn.microsoft.com/en-us/microsoft-copilot-studio/security-and-governance</a:t>
@@ -2802,14 +3257,14 @@
       </p:sp>
       <p:sp>
         <p:nvSpPr>
-          <p:cNvPr id="5" name="Footer"/>
+          <p:cNvPr id="8" name="Footer"/>
           <p:cNvSpPr txBox="1"/>
           <p:nvPr/>
         </p:nvSpPr>
         <p:spPr>
           <a:xfrm>
             <a:off x="685800" y="6250000"/>
-            <a:ext cx="9400000" cy="420000"/>
+            <a:ext cx="10820400" cy="420000"/>
           </a:xfrm>
           <a:prstGeom prst="rect">
             <a:avLst/>
@@ -2836,47 +3291,10 @@
             <a:r>
               <a:rPr lang="en-US" sz="1000">
                 <a:solidFill>
-                  <a:srgbClr val="BCC1C8"/>
-                </a:solidFill>
-              </a:rPr>
-              <a:t>copilot-studio-2026-07-am-michael-kokoro-onnx</a:t>
-            </a:r>
-          </a:p>
-        </p:txBody>
-      </p:sp>
-      <p:sp>
-        <p:nvSpPr>
-          <p:cNvPr id="6" name="Slide number"/>
-          <p:cNvSpPr txBox="1"/>
-          <p:nvPr/>
-        </p:nvSpPr>
-        <p:spPr>
-          <a:xfrm>
-            <a:off x="10100000" y="6250000"/>
-            <a:ext cx="1400000" cy="420000"/>
-          </a:xfrm>
-          <a:prstGeom prst="rect">
-            <a:avLst/>
-          </a:prstGeom>
-          <a:noFill/>
-          <a:ln>
-            <a:noFill/>
-          </a:ln>
-        </p:spPr>
-        <p:txBody>
-          <a:bodyPr wrap="square" lIns="182880" tIns="91440" rIns="182880" bIns="91440" anchor="t">
-            <a:normAutofit/>
-          </a:bodyPr>
-          <a:lstStyle/>
-          <a:p>
-            <a:pPr algn="r"/>
-            <a:r>
-              <a:rPr lang="en-US" sz="1000">
-                <a:solidFill>
-                  <a:srgbClr val="BCC1C8"/>
-                </a:solidFill>
-              </a:rPr>
-              <a:t>6 / 6</a:t>
+                  <a:srgbClr val="626C71"/>
+                </a:solidFill>
+              </a:rPr>
+              <a:t>copilot-studio-2026-08-am-michael-kokoro-onnx</a:t>
             </a:r>
           </a:p>
         </p:txBody>
@@ -2890,59 +3308,59 @@
 </file>
 
 <file path=ppt/theme/theme1.xml><?xml version="1.0" encoding="utf-8"?>
-<a:theme xmlns:a="http://schemas.openxmlformats.org/drawingml/2006/main" name="copilot-studio-deep-navy">
+<a:theme xmlns:a="http://schemas.openxmlformats.org/drawingml/2006/main" name="copilot-studio-2026-brand">
   <a:themeElements>
-    <a:clrScheme name="copilot-studio-deep-navy">
+    <a:clrScheme name="copilot-studio-2026-brand">
       <a:dk1>
-        <a:srgbClr val="FFFFFF"/>
+        <a:srgbClr val="071923"/>
       </a:dk1>
       <a:lt1>
-        <a:srgbClr val="10233A"/>
+        <a:srgbClr val="F4F8FC"/>
       </a:lt1>
       <a:dk2>
-        <a:srgbClr val="1F1F1F"/>
+        <a:srgbClr val="091F2C"/>
       </a:dk2>
       <a:lt2>
-        <a:srgbClr val="F8F8F8"/>
+        <a:srgbClr val="E6F1F9"/>
       </a:lt2>
       <a:accent1>
-        <a:srgbClr val="5A8CFF"/>
+        <a:srgbClr val="006EC3"/>
       </a:accent1>
       <a:accent2>
-        <a:srgbClr val="5B9BD5"/>
+        <a:srgbClr val="50E6FF"/>
       </a:accent2>
       <a:accent3>
-        <a:srgbClr val="70AD47"/>
+        <a:srgbClr val="006EC3"/>
       </a:accent3>
       <a:accent4>
-        <a:srgbClr val="FFC000"/>
+        <a:srgbClr val="06141D"/>
       </a:accent4>
       <a:accent5>
-        <a:srgbClr val="C00000"/>
+        <a:srgbClr val="626C71"/>
       </a:accent5>
       <a:accent6>
-        <a:srgbClr val="7030A0"/>
+        <a:srgbClr val="B42318"/>
       </a:accent6>
       <a:hlink>
-        <a:srgbClr val="5A8CFF"/>
+        <a:srgbClr val="006EC3"/>
       </a:hlink>
       <a:folHlink>
-        <a:srgbClr val="7F7F7F"/>
+        <a:srgbClr val="626C71"/>
       </a:folHlink>
     </a:clrScheme>
-    <a:fontScheme name="copilot-studio-deep-navy">
+    <a:fontScheme name="copilot-studio-2026-brand">
       <a:majorFont>
-        <a:latin typeface="Arial"/>
+        <a:latin typeface="Segoe UI Variable Display"/>
         <a:ea typeface=""/>
         <a:cs typeface=""/>
       </a:majorFont>
       <a:minorFont>
-        <a:latin typeface="Arial"/>
+        <a:latin typeface="Segoe UI Variable Text"/>
         <a:ea typeface=""/>
         <a:cs typeface=""/>
       </a:minorFont>
     </a:fontScheme>
-    <a:fmtScheme name="copilot-studio-deep-navy">
+    <a:fmtScheme name="copilot-studio-2026-brand">
       <a:fillStyleLst>
         <a:solidFill>
           <a:schemeClr val="phClr"/>

</xml_diff>

<commit_message>
feat: regenerate copilot-studio-2026 on media adapter 13
- render four voices with source-seeded Excalidraw strokes
- add video and spatial spectrograms and internal/external alignment evidence

🎨 - Generated by Copilot

Co-authored-by: Copilot <223556219+Copilot@users.noreply.github.com>
</commit_message>
<xml_diff>
--- a/projects/copilot-studio-2026/release/outputs/deck.pptx
+++ b/projects/copilot-studio-2026/release/outputs/deck.pptx
@@ -1467,7 +1467,7 @@
                   <a:srgbClr val="626C71"/>
                 </a:solidFill>
               </a:rPr>
-              <a:t>copilot-studio-2026-08-am-michael-kokoro-onnx</a:t>
+              <a:t>copilot-studio-2026-09-am-michael-kokoro-onnx</a:t>
             </a:r>
           </a:p>
         </p:txBody>
@@ -3294,7 +3294,7 @@
                   <a:srgbClr val="626C71"/>
                 </a:solidFill>
               </a:rPr>
-              <a:t>copilot-studio-2026-08-am-michael-kokoro-onnx</a:t>
+              <a:t>copilot-studio-2026-09-am-michael-kokoro-onnx</a:t>
             </a:r>
           </a:p>
         </p:txBody>

</xml_diff>